<commit_message>
updating figure 3 with new analysis
</commit_message>
<xml_diff>
--- a/figures/figure formatting figure 1.pptx
+++ b/figures/figure formatting figure 1.pptx
@@ -6,8 +6,7 @@
   </p:sldMasterIdLst>
   <p:sldIdLst>
     <p:sldId id="256" r:id="rId2"/>
-    <p:sldId id="257" r:id="rId3"/>
-    <p:sldId id="258" r:id="rId4"/>
+    <p:sldId id="258" r:id="rId3"/>
   </p:sldIdLst>
   <p:sldSz cx="12192000" cy="6858000"/>
   <p:notesSz cx="6858000" cy="9144000"/>
@@ -3439,496 +3438,6 @@
       </p:grpSpPr>
       <p:pic>
         <p:nvPicPr>
-          <p:cNvPr id="7" name="Picture 6">
-            <a:extLst>
-              <a:ext uri="{FF2B5EF4-FFF2-40B4-BE49-F238E27FC236}">
-                <a16:creationId xmlns:a16="http://schemas.microsoft.com/office/drawing/2014/main" id="{7756C63D-CD71-E016-8AA7-895E93B2F33D}"/>
-              </a:ext>
-            </a:extLst>
-          </p:cNvPr>
-          <p:cNvPicPr>
-            <a:picLocks noChangeAspect="1"/>
-          </p:cNvPicPr>
-          <p:nvPr/>
-        </p:nvPicPr>
-        <p:blipFill>
-          <a:blip r:embed="rId2"/>
-          <a:stretch>
-            <a:fillRect/>
-          </a:stretch>
-        </p:blipFill>
-        <p:spPr>
-          <a:xfrm>
-            <a:off x="1958186" y="0"/>
-            <a:ext cx="8275627" cy="6858000"/>
-          </a:xfrm>
-          <a:prstGeom prst="rect">
-            <a:avLst/>
-          </a:prstGeom>
-        </p:spPr>
-      </p:pic>
-      <p:sp>
-        <p:nvSpPr>
-          <p:cNvPr id="8" name="TextBox 7">
-            <a:extLst>
-              <a:ext uri="{FF2B5EF4-FFF2-40B4-BE49-F238E27FC236}">
-                <a16:creationId xmlns:a16="http://schemas.microsoft.com/office/drawing/2014/main" id="{1697CB61-E722-A94A-F0BF-963642DC49E4}"/>
-              </a:ext>
-            </a:extLst>
-          </p:cNvPr>
-          <p:cNvSpPr txBox="1"/>
-          <p:nvPr/>
-        </p:nvSpPr>
-        <p:spPr>
-          <a:xfrm>
-            <a:off x="3906000" y="276924"/>
-            <a:ext cx="604653" cy="246221"/>
-          </a:xfrm>
-          <a:prstGeom prst="rect">
-            <a:avLst/>
-          </a:prstGeom>
-          <a:noFill/>
-        </p:spPr>
-        <p:txBody>
-          <a:bodyPr wrap="none" rtlCol="0">
-            <a:spAutoFit/>
-          </a:bodyPr>
-          <a:lstStyle/>
-          <a:p>
-            <a:r>
-              <a:rPr lang="en-US" sz="1000" b="1" dirty="0"/>
-              <a:t>70 </a:t>
-            </a:r>
-            <a:r>
-              <a:rPr lang="el-GR" sz="1000" b="1" dirty="0"/>
-              <a:t>μ</a:t>
-            </a:r>
-            <a:r>
-              <a:rPr lang="en-US" sz="1000" b="1" dirty="0"/>
-              <a:t>g/L</a:t>
-            </a:r>
-          </a:p>
-        </p:txBody>
-      </p:sp>
-      <p:sp>
-        <p:nvSpPr>
-          <p:cNvPr id="9" name="TextBox 8">
-            <a:extLst>
-              <a:ext uri="{FF2B5EF4-FFF2-40B4-BE49-F238E27FC236}">
-                <a16:creationId xmlns:a16="http://schemas.microsoft.com/office/drawing/2014/main" id="{65351366-11D3-08E7-E96D-2904F942FC3E}"/>
-              </a:ext>
-            </a:extLst>
-          </p:cNvPr>
-          <p:cNvSpPr txBox="1"/>
-          <p:nvPr/>
-        </p:nvSpPr>
-        <p:spPr>
-          <a:xfrm>
-            <a:off x="5867535" y="891440"/>
-            <a:ext cx="604653" cy="246221"/>
-          </a:xfrm>
-          <a:prstGeom prst="rect">
-            <a:avLst/>
-          </a:prstGeom>
-          <a:noFill/>
-        </p:spPr>
-        <p:txBody>
-          <a:bodyPr wrap="none" rtlCol="0">
-            <a:spAutoFit/>
-          </a:bodyPr>
-          <a:lstStyle/>
-          <a:p>
-            <a:r>
-              <a:rPr lang="en-US" sz="1000" b="1" dirty="0"/>
-              <a:t>55 </a:t>
-            </a:r>
-            <a:r>
-              <a:rPr lang="el-GR" sz="1000" b="1" dirty="0"/>
-              <a:t>μ</a:t>
-            </a:r>
-            <a:r>
-              <a:rPr lang="en-US" sz="1000" b="1" dirty="0"/>
-              <a:t>g/L</a:t>
-            </a:r>
-          </a:p>
-        </p:txBody>
-      </p:sp>
-      <p:sp>
-        <p:nvSpPr>
-          <p:cNvPr id="10" name="TextBox 9">
-            <a:extLst>
-              <a:ext uri="{FF2B5EF4-FFF2-40B4-BE49-F238E27FC236}">
-                <a16:creationId xmlns:a16="http://schemas.microsoft.com/office/drawing/2014/main" id="{BB3ECEF2-2C93-3A21-0E84-A6C9876F0850}"/>
-              </a:ext>
-            </a:extLst>
-          </p:cNvPr>
-          <p:cNvSpPr txBox="1"/>
-          <p:nvPr/>
-        </p:nvSpPr>
-        <p:spPr>
-          <a:xfrm>
-            <a:off x="5812578" y="1689095"/>
-            <a:ext cx="604653" cy="246221"/>
-          </a:xfrm>
-          <a:prstGeom prst="rect">
-            <a:avLst/>
-          </a:prstGeom>
-          <a:noFill/>
-        </p:spPr>
-        <p:txBody>
-          <a:bodyPr wrap="none" rtlCol="0">
-            <a:spAutoFit/>
-          </a:bodyPr>
-          <a:lstStyle/>
-          <a:p>
-            <a:r>
-              <a:rPr lang="en-US" sz="1000" b="1" dirty="0"/>
-              <a:t>17 </a:t>
-            </a:r>
-            <a:r>
-              <a:rPr lang="el-GR" sz="1000" b="1" dirty="0"/>
-              <a:t>μ</a:t>
-            </a:r>
-            <a:r>
-              <a:rPr lang="en-US" sz="1000" b="1" dirty="0"/>
-              <a:t>g/L</a:t>
-            </a:r>
-          </a:p>
-        </p:txBody>
-      </p:sp>
-      <p:sp>
-        <p:nvSpPr>
-          <p:cNvPr id="11" name="TextBox 10">
-            <a:extLst>
-              <a:ext uri="{FF2B5EF4-FFF2-40B4-BE49-F238E27FC236}">
-                <a16:creationId xmlns:a16="http://schemas.microsoft.com/office/drawing/2014/main" id="{CDDA4A5E-2BFB-420E-67A6-FF8365238C39}"/>
-              </a:ext>
-            </a:extLst>
-          </p:cNvPr>
-          <p:cNvSpPr txBox="1"/>
-          <p:nvPr/>
-        </p:nvSpPr>
-        <p:spPr>
-          <a:xfrm>
-            <a:off x="5293945" y="1137661"/>
-            <a:ext cx="604653" cy="246221"/>
-          </a:xfrm>
-          <a:prstGeom prst="rect">
-            <a:avLst/>
-          </a:prstGeom>
-          <a:noFill/>
-        </p:spPr>
-        <p:txBody>
-          <a:bodyPr wrap="none" rtlCol="0">
-            <a:spAutoFit/>
-          </a:bodyPr>
-          <a:lstStyle/>
-          <a:p>
-            <a:r>
-              <a:rPr lang="en-US" sz="1000" b="1" dirty="0"/>
-              <a:t>32 </a:t>
-            </a:r>
-            <a:r>
-              <a:rPr lang="el-GR" sz="1000" b="1" dirty="0"/>
-              <a:t>μ</a:t>
-            </a:r>
-            <a:r>
-              <a:rPr lang="en-US" sz="1000" b="1" dirty="0"/>
-              <a:t>g/L</a:t>
-            </a:r>
-          </a:p>
-        </p:txBody>
-      </p:sp>
-      <p:sp>
-        <p:nvSpPr>
-          <p:cNvPr id="12" name="TextBox 11">
-            <a:extLst>
-              <a:ext uri="{FF2B5EF4-FFF2-40B4-BE49-F238E27FC236}">
-                <a16:creationId xmlns:a16="http://schemas.microsoft.com/office/drawing/2014/main" id="{8FC514FF-001D-B9E4-3B27-B925D773188F}"/>
-              </a:ext>
-            </a:extLst>
-          </p:cNvPr>
-          <p:cNvSpPr txBox="1"/>
-          <p:nvPr/>
-        </p:nvSpPr>
-        <p:spPr>
-          <a:xfrm>
-            <a:off x="5148933" y="2023804"/>
-            <a:ext cx="604653" cy="246221"/>
-          </a:xfrm>
-          <a:prstGeom prst="rect">
-            <a:avLst/>
-          </a:prstGeom>
-          <a:noFill/>
-        </p:spPr>
-        <p:txBody>
-          <a:bodyPr wrap="none" rtlCol="0">
-            <a:spAutoFit/>
-          </a:bodyPr>
-          <a:lstStyle/>
-          <a:p>
-            <a:r>
-              <a:rPr lang="en-US" sz="1000" b="1" dirty="0"/>
-              <a:t>26 </a:t>
-            </a:r>
-            <a:r>
-              <a:rPr lang="el-GR" sz="1000" b="1" dirty="0"/>
-              <a:t>μ</a:t>
-            </a:r>
-            <a:r>
-              <a:rPr lang="en-US" sz="1000" b="1" dirty="0"/>
-              <a:t>g/L</a:t>
-            </a:r>
-          </a:p>
-        </p:txBody>
-      </p:sp>
-      <p:sp>
-        <p:nvSpPr>
-          <p:cNvPr id="13" name="TextBox 12">
-            <a:extLst>
-              <a:ext uri="{FF2B5EF4-FFF2-40B4-BE49-F238E27FC236}">
-                <a16:creationId xmlns:a16="http://schemas.microsoft.com/office/drawing/2014/main" id="{358BB497-73DB-0F4C-CF9F-2061D25B1E67}"/>
-              </a:ext>
-            </a:extLst>
-          </p:cNvPr>
-          <p:cNvSpPr txBox="1"/>
-          <p:nvPr/>
-        </p:nvSpPr>
-        <p:spPr>
-          <a:xfrm>
-            <a:off x="8966495" y="1145027"/>
-            <a:ext cx="535724" cy="246221"/>
-          </a:xfrm>
-          <a:prstGeom prst="rect">
-            <a:avLst/>
-          </a:prstGeom>
-          <a:noFill/>
-        </p:spPr>
-        <p:txBody>
-          <a:bodyPr wrap="none" rtlCol="0">
-            <a:spAutoFit/>
-          </a:bodyPr>
-          <a:lstStyle/>
-          <a:p>
-            <a:r>
-              <a:rPr lang="en-US" sz="1000" b="1" dirty="0"/>
-              <a:t>8 </a:t>
-            </a:r>
-            <a:r>
-              <a:rPr lang="el-GR" sz="1000" b="1" dirty="0"/>
-              <a:t>μ</a:t>
-            </a:r>
-            <a:r>
-              <a:rPr lang="en-US" sz="1000" b="1" dirty="0"/>
-              <a:t>g/L</a:t>
-            </a:r>
-          </a:p>
-        </p:txBody>
-      </p:sp>
-      <p:sp>
-        <p:nvSpPr>
-          <p:cNvPr id="14" name="TextBox 13">
-            <a:extLst>
-              <a:ext uri="{FF2B5EF4-FFF2-40B4-BE49-F238E27FC236}">
-                <a16:creationId xmlns:a16="http://schemas.microsoft.com/office/drawing/2014/main" id="{E25EB70F-C398-6DD9-DFA7-EF5E970EEC8E}"/>
-              </a:ext>
-            </a:extLst>
-          </p:cNvPr>
-          <p:cNvSpPr txBox="1"/>
-          <p:nvPr/>
-        </p:nvSpPr>
-        <p:spPr>
-          <a:xfrm>
-            <a:off x="9234357" y="1442874"/>
-            <a:ext cx="535724" cy="246221"/>
-          </a:xfrm>
-          <a:prstGeom prst="rect">
-            <a:avLst/>
-          </a:prstGeom>
-          <a:noFill/>
-        </p:spPr>
-        <p:txBody>
-          <a:bodyPr wrap="none" rtlCol="0">
-            <a:spAutoFit/>
-          </a:bodyPr>
-          <a:lstStyle/>
-          <a:p>
-            <a:r>
-              <a:rPr lang="en-US" sz="1000" b="1" dirty="0"/>
-              <a:t>6 </a:t>
-            </a:r>
-            <a:r>
-              <a:rPr lang="el-GR" sz="1000" b="1" dirty="0"/>
-              <a:t>μ</a:t>
-            </a:r>
-            <a:r>
-              <a:rPr lang="en-US" sz="1000" b="1" dirty="0"/>
-              <a:t>g/L</a:t>
-            </a:r>
-          </a:p>
-        </p:txBody>
-      </p:sp>
-      <p:sp>
-        <p:nvSpPr>
-          <p:cNvPr id="15" name="TextBox 14">
-            <a:extLst>
-              <a:ext uri="{FF2B5EF4-FFF2-40B4-BE49-F238E27FC236}">
-                <a16:creationId xmlns:a16="http://schemas.microsoft.com/office/drawing/2014/main" id="{D50260B2-F46D-A78B-B08F-D828E38F7323}"/>
-              </a:ext>
-            </a:extLst>
-          </p:cNvPr>
-          <p:cNvSpPr txBox="1"/>
-          <p:nvPr/>
-        </p:nvSpPr>
-        <p:spPr>
-          <a:xfrm>
-            <a:off x="6751712" y="1736202"/>
-            <a:ext cx="535724" cy="246221"/>
-          </a:xfrm>
-          <a:prstGeom prst="rect">
-            <a:avLst/>
-          </a:prstGeom>
-          <a:noFill/>
-        </p:spPr>
-        <p:txBody>
-          <a:bodyPr wrap="none" rtlCol="0">
-            <a:spAutoFit/>
-          </a:bodyPr>
-          <a:lstStyle/>
-          <a:p>
-            <a:r>
-              <a:rPr lang="en-US" sz="1000" b="1" dirty="0"/>
-              <a:t>3 </a:t>
-            </a:r>
-            <a:r>
-              <a:rPr lang="el-GR" sz="1000" b="1" dirty="0"/>
-              <a:t>μ</a:t>
-            </a:r>
-            <a:r>
-              <a:rPr lang="en-US" sz="1000" b="1" dirty="0"/>
-              <a:t>g/L</a:t>
-            </a:r>
-          </a:p>
-        </p:txBody>
-      </p:sp>
-      <p:sp>
-        <p:nvSpPr>
-          <p:cNvPr id="16" name="TextBox 15">
-            <a:extLst>
-              <a:ext uri="{FF2B5EF4-FFF2-40B4-BE49-F238E27FC236}">
-                <a16:creationId xmlns:a16="http://schemas.microsoft.com/office/drawing/2014/main" id="{E9AB7B2A-7E4D-0408-ABEC-601263094A30}"/>
-              </a:ext>
-            </a:extLst>
-          </p:cNvPr>
-          <p:cNvSpPr txBox="1"/>
-          <p:nvPr/>
-        </p:nvSpPr>
-        <p:spPr>
-          <a:xfrm>
-            <a:off x="6723949" y="1923839"/>
-            <a:ext cx="535724" cy="246221"/>
-          </a:xfrm>
-          <a:prstGeom prst="rect">
-            <a:avLst/>
-          </a:prstGeom>
-          <a:noFill/>
-        </p:spPr>
-        <p:txBody>
-          <a:bodyPr wrap="none" rtlCol="0">
-            <a:spAutoFit/>
-          </a:bodyPr>
-          <a:lstStyle/>
-          <a:p>
-            <a:r>
-              <a:rPr lang="en-US" sz="1000" b="1" dirty="0"/>
-              <a:t>4 </a:t>
-            </a:r>
-            <a:r>
-              <a:rPr lang="el-GR" sz="1000" b="1" dirty="0"/>
-              <a:t>μ</a:t>
-            </a:r>
-            <a:r>
-              <a:rPr lang="en-US" sz="1000" b="1" dirty="0"/>
-              <a:t>g/L</a:t>
-            </a:r>
-          </a:p>
-        </p:txBody>
-      </p:sp>
-      <p:sp>
-        <p:nvSpPr>
-          <p:cNvPr id="17" name="TextBox 16">
-            <a:extLst>
-              <a:ext uri="{FF2B5EF4-FFF2-40B4-BE49-F238E27FC236}">
-                <a16:creationId xmlns:a16="http://schemas.microsoft.com/office/drawing/2014/main" id="{EF1BB50F-7A45-7180-DD70-14F4999F9A84}"/>
-              </a:ext>
-            </a:extLst>
-          </p:cNvPr>
-          <p:cNvSpPr txBox="1"/>
-          <p:nvPr/>
-        </p:nvSpPr>
-        <p:spPr>
-          <a:xfrm>
-            <a:off x="7487471" y="2104717"/>
-            <a:ext cx="535724" cy="246221"/>
-          </a:xfrm>
-          <a:prstGeom prst="rect">
-            <a:avLst/>
-          </a:prstGeom>
-          <a:noFill/>
-        </p:spPr>
-        <p:txBody>
-          <a:bodyPr wrap="none" rtlCol="0">
-            <a:spAutoFit/>
-          </a:bodyPr>
-          <a:lstStyle/>
-          <a:p>
-            <a:r>
-              <a:rPr lang="en-US" sz="1000" b="1" dirty="0"/>
-              <a:t>5 </a:t>
-            </a:r>
-            <a:r>
-              <a:rPr lang="el-GR" sz="1000" b="1" dirty="0"/>
-              <a:t>μ</a:t>
-            </a:r>
-            <a:r>
-              <a:rPr lang="en-US" sz="1000" b="1" dirty="0"/>
-              <a:t>g/L</a:t>
-            </a:r>
-          </a:p>
-        </p:txBody>
-      </p:sp>
-    </p:spTree>
-    <p:extLst>
-      <p:ext uri="{BB962C8B-B14F-4D97-AF65-F5344CB8AC3E}">
-        <p14:creationId xmlns:p14="http://schemas.microsoft.com/office/powerpoint/2010/main" val="1698480816"/>
-      </p:ext>
-    </p:extLst>
-  </p:cSld>
-  <p:clrMapOvr>
-    <a:masterClrMapping/>
-  </p:clrMapOvr>
-</p:sld>
-</file>
-
-<file path=ppt/slides/slide3.xml><?xml version="1.0" encoding="utf-8"?>
-<p:sld xmlns:a="http://schemas.openxmlformats.org/drawingml/2006/main" xmlns:r="http://schemas.openxmlformats.org/officeDocument/2006/relationships" xmlns:p="http://schemas.openxmlformats.org/presentationml/2006/main">
-  <p:cSld>
-    <p:spTree>
-      <p:nvGrpSpPr>
-        <p:cNvPr id="1" name=""/>
-        <p:cNvGrpSpPr/>
-        <p:nvPr/>
-      </p:nvGrpSpPr>
-      <p:grpSpPr>
-        <a:xfrm>
-          <a:off x="0" y="0"/>
-          <a:ext cx="0" cy="0"/>
-          <a:chOff x="0" y="0"/>
-          <a:chExt cx="0" cy="0"/>
-        </a:xfrm>
-      </p:grpSpPr>
-      <p:pic>
-        <p:nvPicPr>
           <p:cNvPr id="5" name="Picture 4">
             <a:extLst>
               <a:ext uri="{FF2B5EF4-FFF2-40B4-BE49-F238E27FC236}">
@@ -3954,7 +3463,7 @@
         </p:blipFill>
         <p:spPr>
           <a:xfrm>
-            <a:off x="2982461" y="1269487"/>
+            <a:off x="2982460" y="1269487"/>
             <a:ext cx="6227077" cy="4319025"/>
           </a:xfrm>
           <a:prstGeom prst="rect">
@@ -3988,18 +3497,33 @@
           <a:bodyPr wrap="none" rtlCol="0">
             <a:spAutoFit/>
           </a:bodyPr>
-          <a:lstStyle/>
-          <a:p>
-            <a:r>
-              <a:rPr lang="en-US" sz="800" b="1" dirty="0"/>
+          <a:lstStyle>
+            <a:defPPr>
+              <a:defRPr lang="en-US"/>
+            </a:defPPr>
+            <a:lvl1pPr>
+              <a:defRPr sz="800" b="1">
+                <a:effectLst>
+                  <a:glow rad="25400">
+                    <a:schemeClr val="bg1">
+                      <a:alpha val="40000"/>
+                    </a:schemeClr>
+                  </a:glow>
+                </a:effectLst>
+              </a:defRPr>
+            </a:lvl1pPr>
+          </a:lstStyle>
+          <a:p>
+            <a:r>
+              <a:rPr lang="en-US" dirty="0"/>
               <a:t>70 </a:t>
             </a:r>
             <a:r>
-              <a:rPr lang="el-GR" sz="800" b="1" dirty="0"/>
+              <a:rPr lang="el-GR" dirty="0"/>
               <a:t>μ</a:t>
             </a:r>
             <a:r>
-              <a:rPr lang="en-US" sz="800" b="1" dirty="0"/>
+              <a:rPr lang="en-US" dirty="0"/>
               <a:t>g/L</a:t>
             </a:r>
           </a:p>
@@ -4019,7 +3543,7 @@
         </p:nvSpPr>
         <p:spPr>
           <a:xfrm>
-            <a:off x="5875494" y="1884744"/>
+            <a:off x="5911353" y="1629392"/>
             <a:ext cx="519694" cy="215444"/>
           </a:xfrm>
           <a:prstGeom prst="rect">
@@ -4031,18 +3555,33 @@
           <a:bodyPr wrap="none" rtlCol="0">
             <a:spAutoFit/>
           </a:bodyPr>
-          <a:lstStyle/>
-          <a:p>
-            <a:r>
-              <a:rPr lang="en-US" sz="800" b="1" dirty="0"/>
-              <a:t>55 </a:t>
-            </a:r>
-            <a:r>
-              <a:rPr lang="el-GR" sz="800" b="1" dirty="0"/>
+          <a:lstStyle>
+            <a:defPPr>
+              <a:defRPr lang="en-US"/>
+            </a:defPPr>
+            <a:lvl1pPr>
+              <a:defRPr sz="800" b="1">
+                <a:effectLst>
+                  <a:glow rad="25400">
+                    <a:schemeClr val="bg1">
+                      <a:alpha val="40000"/>
+                    </a:schemeClr>
+                  </a:glow>
+                </a:effectLst>
+              </a:defRPr>
+            </a:lvl1pPr>
+          </a:lstStyle>
+          <a:p>
+            <a:r>
+              <a:rPr lang="en-US" dirty="0"/>
+              <a:t>70 </a:t>
+            </a:r>
+            <a:r>
+              <a:rPr lang="el-GR" dirty="0"/>
               <a:t>μ</a:t>
             </a:r>
             <a:r>
-              <a:rPr lang="en-US" sz="800" b="1" dirty="0"/>
+              <a:rPr lang="en-US" dirty="0"/>
               <a:t>g/L</a:t>
             </a:r>
           </a:p>
@@ -4062,7 +3601,7 @@
         </p:nvSpPr>
         <p:spPr>
           <a:xfrm>
-            <a:off x="5884071" y="2460334"/>
+            <a:off x="5875494" y="2420185"/>
             <a:ext cx="519694" cy="215444"/>
           </a:xfrm>
           <a:prstGeom prst="rect">
@@ -4078,7 +3617,7 @@
           <a:p>
             <a:r>
               <a:rPr lang="en-US" sz="800" b="1" dirty="0"/>
-              <a:t>17 </a:t>
+              <a:t>19 </a:t>
             </a:r>
             <a:r>
               <a:rPr lang="el-GR" sz="800" b="1" dirty="0"/>
@@ -4105,7 +3644,7 @@
         </p:nvSpPr>
         <p:spPr>
           <a:xfrm>
-            <a:off x="5562451" y="2100188"/>
+            <a:off x="5615647" y="1844836"/>
             <a:ext cx="519694" cy="215444"/>
           </a:xfrm>
           <a:prstGeom prst="rect">
@@ -4120,15 +3659,21 @@
           <a:lstStyle/>
           <a:p>
             <a:r>
-              <a:rPr lang="en-US" sz="800" b="1" dirty="0"/>
-              <a:t>32 </a:t>
-            </a:r>
-            <a:r>
-              <a:rPr lang="el-GR" sz="800" b="1" dirty="0"/>
+              <a:rPr lang="en-US" sz="800" b="1" dirty="0">
+                <a:effectLst/>
+              </a:rPr>
+              <a:t>42 </a:t>
+            </a:r>
+            <a:r>
+              <a:rPr lang="el-GR" sz="800" b="1" dirty="0">
+                <a:effectLst/>
+              </a:rPr>
               <a:t>μ</a:t>
             </a:r>
             <a:r>
-              <a:rPr lang="en-US" sz="800" b="1" dirty="0"/>
+              <a:rPr lang="en-US" sz="800" b="1" dirty="0">
+                <a:effectLst/>
+              </a:rPr>
               <a:t>g/L</a:t>
             </a:r>
           </a:p>
@@ -4148,7 +3693,7 @@
         </p:nvSpPr>
         <p:spPr>
           <a:xfrm>
-            <a:off x="5474769" y="2712758"/>
+            <a:off x="5316051" y="2735563"/>
             <a:ext cx="519694" cy="215444"/>
           </a:xfrm>
           <a:prstGeom prst="rect">
@@ -4160,18 +3705,27 @@
           <a:bodyPr wrap="none" rtlCol="0">
             <a:spAutoFit/>
           </a:bodyPr>
-          <a:lstStyle/>
-          <a:p>
-            <a:r>
-              <a:rPr lang="en-US" sz="800" b="1" dirty="0"/>
+          <a:lstStyle>
+            <a:defPPr>
+              <a:defRPr lang="en-US"/>
+            </a:defPPr>
+            <a:lvl1pPr>
+              <a:defRPr sz="800" b="1">
+                <a:effectLst/>
+              </a:defRPr>
+            </a:lvl1pPr>
+          </a:lstStyle>
+          <a:p>
+            <a:r>
+              <a:rPr lang="en-US" dirty="0"/>
               <a:t>26 </a:t>
             </a:r>
             <a:r>
-              <a:rPr lang="el-GR" sz="800" b="1" dirty="0"/>
+              <a:rPr lang="el-GR" dirty="0"/>
               <a:t>μ</a:t>
             </a:r>
             <a:r>
-              <a:rPr lang="en-US" sz="800" b="1" dirty="0"/>
+              <a:rPr lang="en-US" dirty="0"/>
               <a:t>g/L</a:t>
             </a:r>
           </a:p>
@@ -4191,7 +3745,7 @@
         </p:nvSpPr>
         <p:spPr>
           <a:xfrm>
-            <a:off x="8153824" y="2130965"/>
+            <a:off x="7815628" y="2109460"/>
             <a:ext cx="465192" cy="215444"/>
           </a:xfrm>
           <a:prstGeom prst="rect">
@@ -4207,7 +3761,7 @@
           <a:p>
             <a:r>
               <a:rPr lang="en-US" sz="800" b="1" dirty="0"/>
-              <a:t>8 </a:t>
+              <a:t>6 </a:t>
             </a:r>
             <a:r>
               <a:rPr lang="el-GR" sz="800" b="1" dirty="0"/>
@@ -4234,7 +3788,7 @@
         </p:nvSpPr>
         <p:spPr>
           <a:xfrm>
-            <a:off x="8396285" y="2324904"/>
+            <a:off x="8136310" y="2324904"/>
             <a:ext cx="465192" cy="215444"/>
           </a:xfrm>
           <a:prstGeom prst="rect">
@@ -4250,7 +3804,7 @@
           <a:p>
             <a:r>
               <a:rPr lang="en-US" sz="800" b="1" dirty="0"/>
-              <a:t>6 </a:t>
+              <a:t>7 </a:t>
             </a:r>
             <a:r>
               <a:rPr lang="el-GR" sz="800" b="1" dirty="0"/>
@@ -4277,7 +3831,7 @@
         </p:nvSpPr>
         <p:spPr>
           <a:xfrm>
-            <a:off x="6488868" y="2476231"/>
+            <a:off x="8622466" y="2485195"/>
             <a:ext cx="465192" cy="215444"/>
           </a:xfrm>
           <a:prstGeom prst="rect">
@@ -4320,7 +3874,7 @@
         </p:nvSpPr>
         <p:spPr>
           <a:xfrm>
-            <a:off x="6573971" y="2632460"/>
+            <a:off x="8470013" y="2632460"/>
             <a:ext cx="465192" cy="215444"/>
           </a:xfrm>
           <a:prstGeom prst="rect">
@@ -4363,7 +3917,7 @@
         </p:nvSpPr>
         <p:spPr>
           <a:xfrm>
-            <a:off x="7194798" y="2764014"/>
+            <a:off x="6683814" y="2755050"/>
             <a:ext cx="465192" cy="215444"/>
           </a:xfrm>
           <a:prstGeom prst="rect">
@@ -4379,7 +3933,7 @@
           <a:p>
             <a:r>
               <a:rPr lang="en-US" sz="800" b="1" dirty="0"/>
-              <a:t>5 </a:t>
+              <a:t>4 </a:t>
             </a:r>
             <a:r>
               <a:rPr lang="el-GR" sz="800" b="1" dirty="0"/>

</xml_diff>

<commit_message>
updating supplemental figures to include Paul
</commit_message>
<xml_diff>
--- a/figures/figure formatting figure 1.pptx
+++ b/figures/figure formatting figure 1.pptx
@@ -7,6 +7,7 @@
   <p:sldIdLst>
     <p:sldId id="256" r:id="rId2"/>
     <p:sldId id="258" r:id="rId3"/>
+    <p:sldId id="259" r:id="rId4"/>
   </p:sldIdLst>
   <p:sldSz cx="12192000" cy="6858000"/>
   <p:notesSz cx="6858000" cy="9144000"/>
@@ -260,7 +261,7 @@
           <a:p>
             <a:fld id="{8BB9B22D-7CCA-405A-AF83-83EB3DB387CD}" type="datetimeFigureOut">
               <a:rPr lang="en-US" smtClean="0"/>
-              <a:t>6/30/2026</a:t>
+              <a:t>7/15/2026</a:t>
             </a:fld>
             <a:endParaRPr lang="en-US"/>
           </a:p>
@@ -458,7 +459,7 @@
           <a:p>
             <a:fld id="{8BB9B22D-7CCA-405A-AF83-83EB3DB387CD}" type="datetimeFigureOut">
               <a:rPr lang="en-US" smtClean="0"/>
-              <a:t>6/30/2026</a:t>
+              <a:t>7/15/2026</a:t>
             </a:fld>
             <a:endParaRPr lang="en-US"/>
           </a:p>
@@ -666,7 +667,7 @@
           <a:p>
             <a:fld id="{8BB9B22D-7CCA-405A-AF83-83EB3DB387CD}" type="datetimeFigureOut">
               <a:rPr lang="en-US" smtClean="0"/>
-              <a:t>6/30/2026</a:t>
+              <a:t>7/15/2026</a:t>
             </a:fld>
             <a:endParaRPr lang="en-US"/>
           </a:p>
@@ -864,7 +865,7 @@
           <a:p>
             <a:fld id="{8BB9B22D-7CCA-405A-AF83-83EB3DB387CD}" type="datetimeFigureOut">
               <a:rPr lang="en-US" smtClean="0"/>
-              <a:t>6/30/2026</a:t>
+              <a:t>7/15/2026</a:t>
             </a:fld>
             <a:endParaRPr lang="en-US"/>
           </a:p>
@@ -1139,7 +1140,7 @@
           <a:p>
             <a:fld id="{8BB9B22D-7CCA-405A-AF83-83EB3DB387CD}" type="datetimeFigureOut">
               <a:rPr lang="en-US" smtClean="0"/>
-              <a:t>6/30/2026</a:t>
+              <a:t>7/15/2026</a:t>
             </a:fld>
             <a:endParaRPr lang="en-US"/>
           </a:p>
@@ -1404,7 +1405,7 @@
           <a:p>
             <a:fld id="{8BB9B22D-7CCA-405A-AF83-83EB3DB387CD}" type="datetimeFigureOut">
               <a:rPr lang="en-US" smtClean="0"/>
-              <a:t>6/30/2026</a:t>
+              <a:t>7/15/2026</a:t>
             </a:fld>
             <a:endParaRPr lang="en-US"/>
           </a:p>
@@ -1816,7 +1817,7 @@
           <a:p>
             <a:fld id="{8BB9B22D-7CCA-405A-AF83-83EB3DB387CD}" type="datetimeFigureOut">
               <a:rPr lang="en-US" smtClean="0"/>
-              <a:t>6/30/2026</a:t>
+              <a:t>7/15/2026</a:t>
             </a:fld>
             <a:endParaRPr lang="en-US"/>
           </a:p>
@@ -1957,7 +1958,7 @@
           <a:p>
             <a:fld id="{8BB9B22D-7CCA-405A-AF83-83EB3DB387CD}" type="datetimeFigureOut">
               <a:rPr lang="en-US" smtClean="0"/>
-              <a:t>6/30/2026</a:t>
+              <a:t>7/15/2026</a:t>
             </a:fld>
             <a:endParaRPr lang="en-US"/>
           </a:p>
@@ -2070,7 +2071,7 @@
           <a:p>
             <a:fld id="{8BB9B22D-7CCA-405A-AF83-83EB3DB387CD}" type="datetimeFigureOut">
               <a:rPr lang="en-US" smtClean="0"/>
-              <a:t>6/30/2026</a:t>
+              <a:t>7/15/2026</a:t>
             </a:fld>
             <a:endParaRPr lang="en-US"/>
           </a:p>
@@ -2381,7 +2382,7 @@
           <a:p>
             <a:fld id="{8BB9B22D-7CCA-405A-AF83-83EB3DB387CD}" type="datetimeFigureOut">
               <a:rPr lang="en-US" smtClean="0"/>
-              <a:t>6/30/2026</a:t>
+              <a:t>7/15/2026</a:t>
             </a:fld>
             <a:endParaRPr lang="en-US"/>
           </a:p>
@@ -2669,7 +2670,7 @@
           <a:p>
             <a:fld id="{8BB9B22D-7CCA-405A-AF83-83EB3DB387CD}" type="datetimeFigureOut">
               <a:rPr lang="en-US" smtClean="0"/>
-              <a:t>6/30/2026</a:t>
+              <a:t>7/15/2026</a:t>
             </a:fld>
             <a:endParaRPr lang="en-US"/>
           </a:p>
@@ -2910,7 +2911,7 @@
           <a:p>
             <a:fld id="{8BB9B22D-7CCA-405A-AF83-83EB3DB387CD}" type="datetimeFigureOut">
               <a:rPr lang="en-US" smtClean="0"/>
-              <a:t>6/30/2026</a:t>
+              <a:t>7/15/2026</a:t>
             </a:fld>
             <a:endParaRPr lang="en-US"/>
           </a:p>
@@ -3959,6 +3960,461 @@
 </p:sld>
 </file>
 
+<file path=ppt/slides/slide3.xml><?xml version="1.0" encoding="utf-8"?>
+<p:sld xmlns:a="http://schemas.openxmlformats.org/drawingml/2006/main" xmlns:r="http://schemas.openxmlformats.org/officeDocument/2006/relationships" xmlns:p="http://schemas.openxmlformats.org/presentationml/2006/main">
+  <p:cSld>
+    <p:spTree>
+      <p:nvGrpSpPr>
+        <p:cNvPr id="1" name=""/>
+        <p:cNvGrpSpPr/>
+        <p:nvPr/>
+      </p:nvGrpSpPr>
+      <p:grpSpPr>
+        <a:xfrm>
+          <a:off x="0" y="0"/>
+          <a:ext cx="0" cy="0"/>
+          <a:chOff x="0" y="0"/>
+          <a:chExt cx="0" cy="0"/>
+        </a:xfrm>
+      </p:grpSpPr>
+      <p:pic>
+        <p:nvPicPr>
+          <p:cNvPr id="27" name="Picture 26">
+            <a:extLst>
+              <a:ext uri="{FF2B5EF4-FFF2-40B4-BE49-F238E27FC236}">
+                <a16:creationId xmlns:a16="http://schemas.microsoft.com/office/drawing/2014/main" id="{6979FB7D-EAD7-6D0D-C1B9-AB8F3E2C6680}"/>
+              </a:ext>
+            </a:extLst>
+          </p:cNvPr>
+          <p:cNvPicPr>
+            <a:picLocks noChangeAspect="1"/>
+          </p:cNvPicPr>
+          <p:nvPr/>
+        </p:nvPicPr>
+        <p:blipFill>
+          <a:blip r:embed="rId2">
+            <a:extLst>
+              <a:ext uri="{28A0092B-C50C-407E-A947-70E740481C1C}">
+                <a14:useLocalDpi xmlns:a14="http://schemas.microsoft.com/office/drawing/2010/main" val="0"/>
+              </a:ext>
+            </a:extLst>
+          </a:blip>
+          <a:srcRect/>
+          <a:stretch/>
+        </p:blipFill>
+        <p:spPr>
+          <a:xfrm>
+            <a:off x="2982461" y="1629152"/>
+            <a:ext cx="6227076" cy="3599695"/>
+          </a:xfrm>
+          <a:prstGeom prst="rect">
+            <a:avLst/>
+          </a:prstGeom>
+        </p:spPr>
+      </p:pic>
+      <p:sp>
+        <p:nvSpPr>
+          <p:cNvPr id="5" name="TextBox 4">
+            <a:extLst>
+              <a:ext uri="{FF2B5EF4-FFF2-40B4-BE49-F238E27FC236}">
+                <a16:creationId xmlns:a16="http://schemas.microsoft.com/office/drawing/2014/main" id="{2C094E48-9A85-3674-696B-5D38CE0F04E3}"/>
+              </a:ext>
+            </a:extLst>
+          </p:cNvPr>
+          <p:cNvSpPr txBox="1"/>
+          <p:nvPr/>
+        </p:nvSpPr>
+        <p:spPr>
+          <a:xfrm>
+            <a:off x="3521529" y="3434006"/>
+            <a:ext cx="535724" cy="215444"/>
+          </a:xfrm>
+          <a:prstGeom prst="rect">
+            <a:avLst/>
+          </a:prstGeom>
+          <a:noFill/>
+        </p:spPr>
+        <p:txBody>
+          <a:bodyPr wrap="none" rtlCol="0">
+            <a:spAutoFit/>
+          </a:bodyPr>
+          <a:lstStyle/>
+          <a:p>
+            <a:r>
+              <a:rPr lang="en-US" sz="800" i="1" dirty="0"/>
+              <a:t>R</a:t>
+            </a:r>
+            <a:r>
+              <a:rPr lang="en-US" sz="800" dirty="0"/>
+              <a:t> = 0.35</a:t>
+            </a:r>
+          </a:p>
+        </p:txBody>
+      </p:sp>
+      <p:sp>
+        <p:nvSpPr>
+          <p:cNvPr id="7" name="TextBox 6">
+            <a:extLst>
+              <a:ext uri="{FF2B5EF4-FFF2-40B4-BE49-F238E27FC236}">
+                <a16:creationId xmlns:a16="http://schemas.microsoft.com/office/drawing/2014/main" id="{B3AC64E1-1424-0FB2-C0D8-5B1B73C5A069}"/>
+              </a:ext>
+            </a:extLst>
+          </p:cNvPr>
+          <p:cNvSpPr txBox="1"/>
+          <p:nvPr/>
+        </p:nvSpPr>
+        <p:spPr>
+          <a:xfrm>
+            <a:off x="4615544" y="3434006"/>
+            <a:ext cx="535724" cy="215444"/>
+          </a:xfrm>
+          <a:prstGeom prst="rect">
+            <a:avLst/>
+          </a:prstGeom>
+          <a:noFill/>
+        </p:spPr>
+        <p:txBody>
+          <a:bodyPr wrap="none" rtlCol="0">
+            <a:spAutoFit/>
+          </a:bodyPr>
+          <a:lstStyle/>
+          <a:p>
+            <a:r>
+              <a:rPr lang="en-US" sz="800" i="1" dirty="0"/>
+              <a:t>R</a:t>
+            </a:r>
+            <a:r>
+              <a:rPr lang="en-US" sz="800" dirty="0"/>
+              <a:t> = 0.57</a:t>
+            </a:r>
+          </a:p>
+        </p:txBody>
+      </p:sp>
+      <p:sp>
+        <p:nvSpPr>
+          <p:cNvPr id="9" name="TextBox 8">
+            <a:extLst>
+              <a:ext uri="{FF2B5EF4-FFF2-40B4-BE49-F238E27FC236}">
+                <a16:creationId xmlns:a16="http://schemas.microsoft.com/office/drawing/2014/main" id="{54911CBF-47DE-5573-9A61-D1022D35593D}"/>
+              </a:ext>
+            </a:extLst>
+          </p:cNvPr>
+          <p:cNvSpPr txBox="1"/>
+          <p:nvPr/>
+        </p:nvSpPr>
+        <p:spPr>
+          <a:xfrm>
+            <a:off x="5655130" y="3434006"/>
+            <a:ext cx="535724" cy="215444"/>
+          </a:xfrm>
+          <a:prstGeom prst="rect">
+            <a:avLst/>
+          </a:prstGeom>
+          <a:noFill/>
+        </p:spPr>
+        <p:txBody>
+          <a:bodyPr wrap="none" rtlCol="0">
+            <a:spAutoFit/>
+          </a:bodyPr>
+          <a:lstStyle/>
+          <a:p>
+            <a:r>
+              <a:rPr lang="en-US" sz="800" i="1" dirty="0"/>
+              <a:t>R</a:t>
+            </a:r>
+            <a:r>
+              <a:rPr lang="en-US" sz="800" dirty="0"/>
+              <a:t> = 0.68</a:t>
+            </a:r>
+          </a:p>
+        </p:txBody>
+      </p:sp>
+      <p:sp>
+        <p:nvSpPr>
+          <p:cNvPr id="11" name="TextBox 10">
+            <a:extLst>
+              <a:ext uri="{FF2B5EF4-FFF2-40B4-BE49-F238E27FC236}">
+                <a16:creationId xmlns:a16="http://schemas.microsoft.com/office/drawing/2014/main" id="{559A2866-BFD1-2160-3A97-9461A78F4E38}"/>
+              </a:ext>
+            </a:extLst>
+          </p:cNvPr>
+          <p:cNvSpPr txBox="1"/>
+          <p:nvPr/>
+        </p:nvSpPr>
+        <p:spPr>
+          <a:xfrm>
+            <a:off x="6772872" y="3434006"/>
+            <a:ext cx="535724" cy="215444"/>
+          </a:xfrm>
+          <a:prstGeom prst="rect">
+            <a:avLst/>
+          </a:prstGeom>
+          <a:noFill/>
+        </p:spPr>
+        <p:txBody>
+          <a:bodyPr wrap="none" rtlCol="0">
+            <a:spAutoFit/>
+          </a:bodyPr>
+          <a:lstStyle/>
+          <a:p>
+            <a:r>
+              <a:rPr lang="en-US" sz="800" i="1" dirty="0"/>
+              <a:t>R</a:t>
+            </a:r>
+            <a:r>
+              <a:rPr lang="en-US" sz="800" dirty="0"/>
+              <a:t> = 0.84</a:t>
+            </a:r>
+          </a:p>
+        </p:txBody>
+      </p:sp>
+      <p:sp>
+        <p:nvSpPr>
+          <p:cNvPr id="13" name="TextBox 12">
+            <a:extLst>
+              <a:ext uri="{FF2B5EF4-FFF2-40B4-BE49-F238E27FC236}">
+                <a16:creationId xmlns:a16="http://schemas.microsoft.com/office/drawing/2014/main" id="{2F07AD30-FA8E-82D6-6FE0-DE01BDFD35CE}"/>
+              </a:ext>
+            </a:extLst>
+          </p:cNvPr>
+          <p:cNvSpPr txBox="1"/>
+          <p:nvPr/>
+        </p:nvSpPr>
+        <p:spPr>
+          <a:xfrm>
+            <a:off x="7823344" y="3434006"/>
+            <a:ext cx="535724" cy="215444"/>
+          </a:xfrm>
+          <a:prstGeom prst="rect">
+            <a:avLst/>
+          </a:prstGeom>
+          <a:noFill/>
+        </p:spPr>
+        <p:txBody>
+          <a:bodyPr wrap="none" rtlCol="0">
+            <a:spAutoFit/>
+          </a:bodyPr>
+          <a:lstStyle/>
+          <a:p>
+            <a:r>
+              <a:rPr lang="en-US" sz="800" i="1" dirty="0"/>
+              <a:t>R</a:t>
+            </a:r>
+            <a:r>
+              <a:rPr lang="en-US" sz="800" dirty="0"/>
+              <a:t> = 0.29</a:t>
+            </a:r>
+          </a:p>
+        </p:txBody>
+      </p:sp>
+      <p:sp>
+        <p:nvSpPr>
+          <p:cNvPr id="15" name="TextBox 14">
+            <a:extLst>
+              <a:ext uri="{FF2B5EF4-FFF2-40B4-BE49-F238E27FC236}">
+                <a16:creationId xmlns:a16="http://schemas.microsoft.com/office/drawing/2014/main" id="{85E7B40E-4BB3-DE5E-CDF2-24BD795C93CF}"/>
+              </a:ext>
+            </a:extLst>
+          </p:cNvPr>
+          <p:cNvSpPr txBox="1"/>
+          <p:nvPr/>
+        </p:nvSpPr>
+        <p:spPr>
+          <a:xfrm>
+            <a:off x="3521529" y="2051956"/>
+            <a:ext cx="535724" cy="215444"/>
+          </a:xfrm>
+          <a:prstGeom prst="rect">
+            <a:avLst/>
+          </a:prstGeom>
+          <a:noFill/>
+        </p:spPr>
+        <p:txBody>
+          <a:bodyPr wrap="none" rtlCol="0">
+            <a:spAutoFit/>
+          </a:bodyPr>
+          <a:lstStyle/>
+          <a:p>
+            <a:r>
+              <a:rPr lang="en-US" sz="800" i="1" dirty="0"/>
+              <a:t>R</a:t>
+            </a:r>
+            <a:r>
+              <a:rPr lang="en-US" sz="800" dirty="0"/>
+              <a:t> = 0.91</a:t>
+            </a:r>
+          </a:p>
+        </p:txBody>
+      </p:sp>
+      <p:sp>
+        <p:nvSpPr>
+          <p:cNvPr id="17" name="TextBox 16">
+            <a:extLst>
+              <a:ext uri="{FF2B5EF4-FFF2-40B4-BE49-F238E27FC236}">
+                <a16:creationId xmlns:a16="http://schemas.microsoft.com/office/drawing/2014/main" id="{60949898-9F90-24B0-3392-C552C775913F}"/>
+              </a:ext>
+            </a:extLst>
+          </p:cNvPr>
+          <p:cNvSpPr txBox="1"/>
+          <p:nvPr/>
+        </p:nvSpPr>
+        <p:spPr>
+          <a:xfrm>
+            <a:off x="4577443" y="2051956"/>
+            <a:ext cx="535724" cy="215444"/>
+          </a:xfrm>
+          <a:prstGeom prst="rect">
+            <a:avLst/>
+          </a:prstGeom>
+          <a:noFill/>
+        </p:spPr>
+        <p:txBody>
+          <a:bodyPr wrap="none" rtlCol="0">
+            <a:spAutoFit/>
+          </a:bodyPr>
+          <a:lstStyle/>
+          <a:p>
+            <a:r>
+              <a:rPr lang="en-US" sz="800" i="1" dirty="0"/>
+              <a:t>R</a:t>
+            </a:r>
+            <a:r>
+              <a:rPr lang="en-US" sz="800" dirty="0"/>
+              <a:t> = 0.88</a:t>
+            </a:r>
+          </a:p>
+        </p:txBody>
+      </p:sp>
+      <p:sp>
+        <p:nvSpPr>
+          <p:cNvPr id="19" name="TextBox 18">
+            <a:extLst>
+              <a:ext uri="{FF2B5EF4-FFF2-40B4-BE49-F238E27FC236}">
+                <a16:creationId xmlns:a16="http://schemas.microsoft.com/office/drawing/2014/main" id="{5034425F-EF19-ADC8-32E3-0C5FA3350438}"/>
+              </a:ext>
+            </a:extLst>
+          </p:cNvPr>
+          <p:cNvSpPr txBox="1"/>
+          <p:nvPr/>
+        </p:nvSpPr>
+        <p:spPr>
+          <a:xfrm>
+            <a:off x="5655130" y="2051956"/>
+            <a:ext cx="535724" cy="215444"/>
+          </a:xfrm>
+          <a:prstGeom prst="rect">
+            <a:avLst/>
+          </a:prstGeom>
+          <a:noFill/>
+        </p:spPr>
+        <p:txBody>
+          <a:bodyPr wrap="none" rtlCol="0">
+            <a:spAutoFit/>
+          </a:bodyPr>
+          <a:lstStyle/>
+          <a:p>
+            <a:r>
+              <a:rPr lang="en-US" sz="800" i="1" dirty="0"/>
+              <a:t>R</a:t>
+            </a:r>
+            <a:r>
+              <a:rPr lang="en-US" sz="800" dirty="0"/>
+              <a:t> = 0.85</a:t>
+            </a:r>
+          </a:p>
+        </p:txBody>
+      </p:sp>
+      <p:sp>
+        <p:nvSpPr>
+          <p:cNvPr id="21" name="TextBox 20">
+            <a:extLst>
+              <a:ext uri="{FF2B5EF4-FFF2-40B4-BE49-F238E27FC236}">
+                <a16:creationId xmlns:a16="http://schemas.microsoft.com/office/drawing/2014/main" id="{3D9F8506-1F7D-4264-398A-A375FFC09D6E}"/>
+              </a:ext>
+            </a:extLst>
+          </p:cNvPr>
+          <p:cNvSpPr txBox="1"/>
+          <p:nvPr/>
+        </p:nvSpPr>
+        <p:spPr>
+          <a:xfrm>
+            <a:off x="6732817" y="2051956"/>
+            <a:ext cx="535724" cy="215444"/>
+          </a:xfrm>
+          <a:prstGeom prst="rect">
+            <a:avLst/>
+          </a:prstGeom>
+          <a:noFill/>
+        </p:spPr>
+        <p:txBody>
+          <a:bodyPr wrap="none" rtlCol="0">
+            <a:spAutoFit/>
+          </a:bodyPr>
+          <a:lstStyle/>
+          <a:p>
+            <a:r>
+              <a:rPr lang="en-US" sz="800" i="1" dirty="0"/>
+              <a:t>R</a:t>
+            </a:r>
+            <a:r>
+              <a:rPr lang="en-US" sz="800" dirty="0"/>
+              <a:t> = 0.63</a:t>
+            </a:r>
+          </a:p>
+        </p:txBody>
+      </p:sp>
+      <p:sp>
+        <p:nvSpPr>
+          <p:cNvPr id="23" name="TextBox 22">
+            <a:extLst>
+              <a:ext uri="{FF2B5EF4-FFF2-40B4-BE49-F238E27FC236}">
+                <a16:creationId xmlns:a16="http://schemas.microsoft.com/office/drawing/2014/main" id="{A5B8A62E-809F-0108-8F3B-10CCD1546809}"/>
+              </a:ext>
+            </a:extLst>
+          </p:cNvPr>
+          <p:cNvSpPr txBox="1"/>
+          <p:nvPr/>
+        </p:nvSpPr>
+        <p:spPr>
+          <a:xfrm>
+            <a:off x="8042220" y="2051956"/>
+            <a:ext cx="535724" cy="215444"/>
+          </a:xfrm>
+          <a:prstGeom prst="rect">
+            <a:avLst/>
+          </a:prstGeom>
+          <a:noFill/>
+        </p:spPr>
+        <p:txBody>
+          <a:bodyPr wrap="none" rtlCol="0">
+            <a:spAutoFit/>
+          </a:bodyPr>
+          <a:lstStyle/>
+          <a:p>
+            <a:r>
+              <a:rPr lang="en-US" sz="800" i="1" dirty="0"/>
+              <a:t>R</a:t>
+            </a:r>
+            <a:r>
+              <a:rPr lang="en-US" sz="800" dirty="0"/>
+              <a:t> = 0.89</a:t>
+            </a:r>
+          </a:p>
+        </p:txBody>
+      </p:sp>
+    </p:spTree>
+    <p:extLst>
+      <p:ext uri="{BB962C8B-B14F-4D97-AF65-F5344CB8AC3E}">
+        <p14:creationId xmlns:p14="http://schemas.microsoft.com/office/powerpoint/2010/main" val="3111694073"/>
+      </p:ext>
+    </p:extLst>
+  </p:cSld>
+  <p:clrMapOvr>
+    <a:masterClrMapping/>
+  </p:clrMapOvr>
+</p:sld>
+</file>
+
 <file path=ppt/theme/theme1.xml><?xml version="1.0" encoding="utf-8"?>
 <a:theme xmlns:a="http://schemas.openxmlformats.org/drawingml/2006/main" name="Office Theme">
   <a:themeElements>

</xml_diff>